<commit_message>
Add the layer-1/layer-2 handoff slide to the judging deck
New slide 8, "This is layer 2. Someone else is building layer 1." -
between "who needs this" and "close". States the two-layer split (layer 1:
due diligence to exhaustion, hands off only the residual; layer 2:
everything in this deck), the one contract property worth a judge's
attention ("looked and it's not there" != "never looked" - enforced at
construction, not a convention), and the Finding/OpenItem field shapes
next to a note that they were checked field-for-field against the actual
running code (refute/handoff.py) rather than asserted from the spec alone.

9 slides now. Re-verified: all 9 pass the shape-bounds check. Same
verification gap as before applies to the new slide - qlmanage only ever
thumbnails slide 1, so slides 2-9's text-fit is unconfirmed visually.

🤖 Generated with [Claude Code](https://claude.com/claude-code)
Co-Authored-By: Claude Sonnet 5 <noreply@anthropic.com>
</commit_message>
<xml_diff>
--- a/talks/reagent_judging_5min.pptx
+++ b/talks/reagent_judging_5min.pptx
@@ -13,6 +13,7 @@
     <p:sldId id="261" r:id="rId12"/>
     <p:sldId id="262" r:id="rId13"/>
     <p:sldId id="263" r:id="rId14"/>
+    <p:sldId id="264" r:id="rId15"/>
   </p:sldIdLst>
   <p:sldSz cx="12191695" cy="6858000" type="screen4x3"/>
   <p:notesSz cx="6858000" cy="9144000"/>
@@ -5792,7 +5793,7 @@
                 </a:solidFill>
                 <a:latin typeface="Arial"/>
               </a:rPr>
-              <a:t>THE LINE WORTH HAVING READY</a:t>
+              <a:t>TWO BUILDERS, ONE SEAM</a:t>
             </a:r>
           </a:p>
         </p:txBody>
@@ -5826,7 +5827,7 @@
                 </a:solidFill>
                 <a:latin typeface="Arial"/>
               </a:rPr>
-              <a:t>The common failure isn't malicious AI biology.</a:t>
+              <a:t>This is layer 2. Someone else is building layer 1.</a:t>
             </a:r>
           </a:p>
         </p:txBody>
@@ -5839,8 +5840,8 @@
         </p:nvSpPr>
         <p:spPr>
           <a:xfrm>
-            <a:off x="640080" y="1920240"/>
-            <a:ext cx="10881360" cy="1737360"/>
+            <a:off x="640080" y="1874519"/>
+            <a:ext cx="6309360" cy="2377440"/>
           </a:xfrm>
           <a:prstGeom prst="rect">
             <a:avLst/>
@@ -5853,30 +5854,53 @@
           </a:bodyPr>
           <a:lstStyle/>
           <a:p>
-            <a:r>
-              <a:rPr sz="2000" b="0" i="0">
+            <a:pPr>
+              <a:spcAft>
+                <a:spcPts val="1800"/>
+              </a:spcAft>
+            </a:pPr>
+            <a:r>
+              <a:rPr sz="1700" b="1" i="0">
+                <a:solidFill>
+                  <a:srgbClr val="0F2A4A"/>
+                </a:solidFill>
+                <a:latin typeface="Arial"/>
+              </a:rPr>
+              <a:t>Layer 1 —  </a:t>
+            </a:r>
+            <a:r>
+              <a:rPr sz="1700" b="0" i="0">
                 <a:solidFill>
                   <a:srgbClr val="1A1D21"/>
                 </a:solidFill>
                 <a:latin typeface="Arial"/>
               </a:rPr>
-              <a:t>It's incompetent AI-designed biology — an agent proposing an experiment that cannot answer its own question, and nobody catching it because there's no simulator in the loop.</a:t>
+              <a:t>due diligence to exhaustion. Checks a hypothesis against the data and the literature until nothing left changes the answer, then either stops — resolved, no handoff — or hands off the one residual only a bench can settle.</a:t>
             </a:r>
           </a:p>
           <a:p>
             <a:pPr>
-              <a:spcBef>
-                <a:spcPts val="1000"/>
-              </a:spcBef>
+              <a:spcAft>
+                <a:spcPts val="1800"/>
+              </a:spcAft>
             </a:pPr>
             <a:r>
-              <a:rPr sz="2000" b="1" i="0">
+              <a:rPr sz="1700" b="1" i="0">
                 <a:solidFill>
                   <a:srgbClr val="0F2A4A"/>
                 </a:solidFill>
                 <a:latin typeface="Arial"/>
               </a:rPr>
-              <a:t>That failure is measurable. This measures it against primary data.</a:t>
+              <a:t>Layer 2 —  </a:t>
+            </a:r>
+            <a:r>
+              <a:rPr sz="1700" b="0" i="0">
+                <a:solidFill>
+                  <a:srgbClr val="1A1D21"/>
+                </a:solidFill>
+                <a:latin typeface="Arial"/>
+              </a:rPr>
+              <a:t>everything in this deck. Designs the experiment for that residual, and refuses honestly when no protocol can model it.</a:t>
             </a:r>
           </a:p>
         </p:txBody>
@@ -5889,7 +5913,7 @@
         </p:nvCxnSpPr>
         <p:spPr>
           <a:xfrm>
-            <a:off x="640080" y="3931920"/>
+            <a:off x="640080" y="4434840"/>
             <a:ext cx="10908792" cy="0"/>
           </a:xfrm>
           <a:prstGeom prst="line">
@@ -5924,6 +5948,637 @@
         </p:nvSpPr>
         <p:spPr>
           <a:xfrm>
+            <a:off x="640080" y="4663440"/>
+            <a:ext cx="6309360" cy="1645920"/>
+          </a:xfrm>
+          <a:prstGeom prst="rect">
+            <a:avLst/>
+          </a:prstGeom>
+          <a:noFill/>
+        </p:spPr>
+        <p:txBody>
+          <a:bodyPr wrap="square">
+            <a:noAutofit/>
+          </a:bodyPr>
+          <a:lstStyle/>
+          <a:p>
+            <a:r>
+              <a:rPr sz="1500" b="0" i="0">
+                <a:solidFill>
+                  <a:srgbClr val="5B636C"/>
+                </a:solidFill>
+                <a:latin typeface="Arial"/>
+              </a:rPr>
+              <a:t>The contract, verified against the running code, not just agreed in prose:</a:t>
+            </a:r>
+          </a:p>
+          <a:p>
+            <a:pPr>
+              <a:spcBef>
+                <a:spcPts val="800"/>
+              </a:spcBef>
+            </a:pPr>
+            <a:r>
+              <a:rPr sz="1900" b="1" i="0">
+                <a:solidFill>
+                  <a:srgbClr val="0F2A4A"/>
+                </a:solidFill>
+                <a:latin typeface="Arial"/>
+              </a:rPr>
+              <a:t>“Looked and it's not there” ≠ “never looked.”</a:t>
+            </a:r>
+          </a:p>
+          <a:p>
+            <a:pPr>
+              <a:spcBef>
+                <a:spcPts val="400"/>
+              </a:spcBef>
+            </a:pPr>
+            <a:r>
+              <a:rPr sz="1400" b="0" i="1">
+                <a:solidFill>
+                  <a:srgbClr val="5B636C"/>
+                </a:solidFill>
+                <a:latin typeface="Arial"/>
+              </a:rPr>
+              <a:t>Enforced at construction — a claim of literature silence with no recorded query raises, not a convention anyone could skip.</a:t>
+            </a:r>
+          </a:p>
+        </p:txBody>
+      </p:sp>
+      <p:sp>
+        <p:nvSpPr>
+          <p:cNvPr id="7" name="Rounded Rectangle 6"/>
+          <p:cNvSpPr/>
+          <p:nvPr/>
+        </p:nvSpPr>
+        <p:spPr>
+          <a:xfrm>
+            <a:off x="7315200" y="1874519"/>
+            <a:ext cx="4206240" cy="4434840"/>
+          </a:xfrm>
+          <a:prstGeom prst="roundRect">
+            <a:avLst>
+              <a:gd name="adj" fmla="val 4000"/>
+            </a:avLst>
+          </a:prstGeom>
+          <a:solidFill>
+            <a:srgbClr val="14171A"/>
+          </a:solidFill>
+          <a:ln>
+            <a:noFill/>
+          </a:ln>
+          <a:effectLst/>
+        </p:spPr>
+        <p:style>
+          <a:lnRef idx="1">
+            <a:schemeClr val="accent1"/>
+          </a:lnRef>
+          <a:fillRef idx="3">
+            <a:schemeClr val="accent1"/>
+          </a:fillRef>
+          <a:effectRef idx="2">
+            <a:schemeClr val="accent1"/>
+          </a:effectRef>
+          <a:fontRef idx="minor">
+            <a:schemeClr val="lt1"/>
+          </a:fontRef>
+        </p:style>
+        <p:txBody>
+          <a:bodyPr rtlCol="0" anchor="ctr" wrap="square" lIns="274320" rIns="274320" tIns="201168" bIns="201168">
+            <a:noAutofit/>
+          </a:bodyPr>
+          <a:lstStyle/>
+          <a:p>
+            <a:pPr algn="ctr">
+              <a:spcAft>
+                <a:spcPts val="400"/>
+              </a:spcAft>
+            </a:pPr>
+            <a:r>
+              <a:rPr sz="1350" b="1" i="0">
+                <a:solidFill>
+                  <a:srgbClr val="E8EAED"/>
+                </a:solidFill>
+                <a:latin typeface="Courier New"/>
+              </a:rPr>
+              <a:t>Finding(</a:t>
+            </a:r>
+          </a:p>
+          <a:p>
+            <a:pPr>
+              <a:spcAft>
+                <a:spcPts val="400"/>
+              </a:spcAft>
+            </a:pPr>
+            <a:r>
+              <a:rPr sz="1350" b="0" i="0">
+                <a:solidFill>
+                  <a:srgbClr val="8A929C"/>
+                </a:solidFill>
+                <a:latin typeface="Courier New"/>
+              </a:rPr>
+              <a:t>  statement, kind,</a:t>
+            </a:r>
+          </a:p>
+          <a:p>
+            <a:pPr>
+              <a:spcAft>
+                <a:spcPts val="400"/>
+              </a:spcAft>
+            </a:pPr>
+            <a:r>
+              <a:rPr sz="1350" b="0" i="0">
+                <a:solidFill>
+                  <a:srgbClr val="8A929C"/>
+                </a:solidFill>
+                <a:latin typeface="Courier New"/>
+              </a:rPr>
+              <a:t>  provenance, source,</a:t>
+            </a:r>
+          </a:p>
+          <a:p>
+            <a:pPr>
+              <a:spcAft>
+                <a:spcPts val="400"/>
+              </a:spcAft>
+            </a:pPr>
+            <a:r>
+              <a:rPr sz="1350" b="0" i="0">
+                <a:solidFill>
+                  <a:srgbClr val="8A929C"/>
+                </a:solidFill>
+                <a:latin typeface="Courier New"/>
+              </a:rPr>
+              <a:t>  quote, scope,</a:t>
+            </a:r>
+          </a:p>
+          <a:p>
+            <a:pPr>
+              <a:spcAft>
+                <a:spcPts val="400"/>
+              </a:spcAft>
+            </a:pPr>
+            <a:r>
+              <a:rPr sz="1350" b="0" i="0">
+                <a:solidFill>
+                  <a:srgbClr val="8A929C"/>
+                </a:solidFill>
+                <a:latin typeface="Courier New"/>
+              </a:rPr>
+              <a:t>  value, units</a:t>
+            </a:r>
+          </a:p>
+          <a:p>
+            <a:pPr>
+              <a:spcAft>
+                <a:spcPts val="400"/>
+              </a:spcAft>
+            </a:pPr>
+            <a:r>
+              <a:rPr sz="1350" b="1" i="0">
+                <a:solidFill>
+                  <a:srgbClr val="E8EAED"/>
+                </a:solidFill>
+                <a:latin typeface="Courier New"/>
+              </a:rPr>
+              <a:t>)</a:t>
+            </a:r>
+          </a:p>
+          <a:p>
+            <a:pPr>
+              <a:spcAft>
+                <a:spcPts val="400"/>
+              </a:spcAft>
+            </a:pPr>
+            <a:r>
+              <a:rPr sz="1350" b="0" i="0">
+                <a:solidFill>
+                  <a:srgbClr val="E8EAED"/>
+                </a:solidFill>
+                <a:latin typeface="Courier New"/>
+              </a:rPr>
+              <a:t> </a:t>
+            </a:r>
+          </a:p>
+          <a:p>
+            <a:pPr>
+              <a:spcAft>
+                <a:spcPts val="400"/>
+              </a:spcAft>
+            </a:pPr>
+            <a:r>
+              <a:rPr sz="1350" b="1" i="0">
+                <a:solidFill>
+                  <a:srgbClr val="E8EAED"/>
+                </a:solidFill>
+                <a:latin typeface="Courier New"/>
+              </a:rPr>
+              <a:t>OpenItem(</a:t>
+            </a:r>
+          </a:p>
+          <a:p>
+            <a:pPr>
+              <a:spcAft>
+                <a:spcPts val="400"/>
+              </a:spcAft>
+            </a:pPr>
+            <a:r>
+              <a:rPr sz="1350" b="0" i="0">
+                <a:solidFill>
+                  <a:srgbClr val="8A929C"/>
+                </a:solidFill>
+                <a:latin typeface="Courier New"/>
+              </a:rPr>
+              <a:t>  statement, why,</a:t>
+            </a:r>
+          </a:p>
+          <a:p>
+            <a:pPr>
+              <a:spcAft>
+                <a:spcPts val="400"/>
+              </a:spcAft>
+            </a:pPr>
+            <a:r>
+              <a:rPr sz="1350" b="0" i="0">
+                <a:solidFill>
+                  <a:srgbClr val="8A929C"/>
+                </a:solidFill>
+                <a:latin typeface="Courier New"/>
+              </a:rPr>
+              <a:t>  searched, queries_run</a:t>
+            </a:r>
+          </a:p>
+          <a:p>
+            <a:pPr>
+              <a:spcAft>
+                <a:spcPts val="400"/>
+              </a:spcAft>
+            </a:pPr>
+            <a:r>
+              <a:rPr sz="1350" b="1" i="0">
+                <a:solidFill>
+                  <a:srgbClr val="E8EAED"/>
+                </a:solidFill>
+                <a:latin typeface="Courier New"/>
+              </a:rPr>
+              <a:t>)</a:t>
+            </a:r>
+          </a:p>
+          <a:p>
+            <a:pPr>
+              <a:spcAft>
+                <a:spcPts val="400"/>
+              </a:spcAft>
+            </a:pPr>
+            <a:r>
+              <a:rPr sz="1350" b="0" i="0">
+                <a:solidFill>
+                  <a:srgbClr val="E8EAED"/>
+                </a:solidFill>
+                <a:latin typeface="Courier New"/>
+              </a:rPr>
+              <a:t> </a:t>
+            </a:r>
+          </a:p>
+          <a:p>
+            <a:pPr>
+              <a:spcAft>
+                <a:spcPts val="400"/>
+              </a:spcAft>
+            </a:pPr>
+            <a:r>
+              <a:rPr sz="1350" b="1" i="0">
+                <a:solidFill>
+                  <a:srgbClr val="1E7B4D"/>
+                </a:solidFill>
+                <a:latin typeface="Courier New"/>
+              </a:rPr>
+              <a:t>field-for-field match</a:t>
+            </a:r>
+          </a:p>
+          <a:p>
+            <a:pPr>
+              <a:spcAft>
+                <a:spcPts val="400"/>
+              </a:spcAft>
+            </a:pPr>
+            <a:r>
+              <a:rPr sz="1350" b="0" i="0">
+                <a:solidFill>
+                  <a:srgbClr val="1E7B4D"/>
+                </a:solidFill>
+                <a:latin typeface="Courier New"/>
+              </a:rPr>
+              <a:t>to the layer-1 SPEC —</a:t>
+            </a:r>
+          </a:p>
+          <a:p>
+            <a:pPr>
+              <a:spcAft>
+                <a:spcPts val="400"/>
+              </a:spcAft>
+            </a:pPr>
+            <a:r>
+              <a:rPr sz="1350" b="0" i="0">
+                <a:solidFill>
+                  <a:srgbClr val="8A929C"/>
+                </a:solidFill>
+                <a:latin typeface="Courier New"/>
+              </a:rPr>
+              <a:t>not aspirational,</a:t>
+            </a:r>
+          </a:p>
+          <a:p>
+            <a:pPr>
+              <a:spcAft>
+                <a:spcPts val="400"/>
+              </a:spcAft>
+            </a:pPr>
+            <a:r>
+              <a:rPr sz="1350" b="0" i="0">
+                <a:solidFill>
+                  <a:srgbClr val="8A929C"/>
+                </a:solidFill>
+                <a:latin typeface="Courier New"/>
+              </a:rPr>
+              <a:t>checked against</a:t>
+            </a:r>
+          </a:p>
+          <a:p>
+            <a:pPr>
+              <a:spcAft>
+                <a:spcPts val="400"/>
+              </a:spcAft>
+            </a:pPr>
+            <a:r>
+              <a:rPr sz="1350" b="0" i="0">
+                <a:solidFill>
+                  <a:srgbClr val="E8EAED"/>
+                </a:solidFill>
+                <a:latin typeface="Courier New"/>
+              </a:rPr>
+              <a:t>refute/handoff.py</a:t>
+            </a:r>
+          </a:p>
+        </p:txBody>
+      </p:sp>
+      <p:sp>
+        <p:nvSpPr>
+          <p:cNvPr id="8" name="TextBox 7"/>
+          <p:cNvSpPr txBox="1"/>
+          <p:nvPr/>
+        </p:nvSpPr>
+        <p:spPr>
+          <a:xfrm>
+            <a:off x="640080" y="6473952"/>
+            <a:ext cx="5486400" cy="320040"/>
+          </a:xfrm>
+          <a:prstGeom prst="rect">
+            <a:avLst/>
+          </a:prstGeom>
+          <a:noFill/>
+        </p:spPr>
+        <p:txBody>
+          <a:bodyPr wrap="square">
+            <a:noAutofit/>
+          </a:bodyPr>
+          <a:lstStyle/>
+          <a:p>
+            <a:r>
+              <a:rPr sz="1000" b="0" i="0">
+                <a:solidFill>
+                  <a:srgbClr val="5B636C"/>
+                </a:solidFill>
+                <a:latin typeface="Arial"/>
+              </a:rPr>
+              <a:t>refute — re:AGENT, Track B</a:t>
+            </a:r>
+          </a:p>
+        </p:txBody>
+      </p:sp>
+      <p:sp>
+        <p:nvSpPr>
+          <p:cNvPr id="9" name="TextBox 8"/>
+          <p:cNvSpPr txBox="1"/>
+          <p:nvPr/>
+        </p:nvSpPr>
+        <p:spPr>
+          <a:xfrm>
+            <a:off x="10881360" y="6473952"/>
+            <a:ext cx="640080" cy="320040"/>
+          </a:xfrm>
+          <a:prstGeom prst="rect">
+            <a:avLst/>
+          </a:prstGeom>
+          <a:noFill/>
+        </p:spPr>
+        <p:txBody>
+          <a:bodyPr wrap="square">
+            <a:noAutofit/>
+          </a:bodyPr>
+          <a:lstStyle/>
+          <a:p>
+            <a:pPr algn="r"/>
+            <a:r>
+              <a:rPr sz="1000" b="0" i="0">
+                <a:solidFill>
+                  <a:srgbClr val="5B636C"/>
+                </a:solidFill>
+                <a:latin typeface="Arial"/>
+              </a:rPr>
+              <a:t>8</a:t>
+            </a:r>
+          </a:p>
+        </p:txBody>
+      </p:sp>
+    </p:spTree>
+  </p:cSld>
+  <p:clrMapOvr>
+    <a:masterClrMapping/>
+  </p:clrMapOvr>
+</p:sld>
+</file>
+
+<file path=ppt/slides/slide9.xml><?xml version="1.0" encoding="utf-8"?>
+<p:sld xmlns:a="http://schemas.openxmlformats.org/drawingml/2006/main" xmlns:p="http://schemas.openxmlformats.org/presentationml/2006/main" xmlns:r="http://schemas.openxmlformats.org/officeDocument/2006/relationships">
+  <p:cSld>
+    <p:bg>
+      <p:bgPr>
+        <a:solidFill>
+          <a:srgbClr val="FFFFFF"/>
+        </a:solidFill>
+        <a:effectLst/>
+      </p:bgPr>
+    </p:bg>
+    <p:spTree>
+      <p:nvGrpSpPr>
+        <p:cNvPr id="1" name=""/>
+        <p:cNvGrpSpPr/>
+        <p:nvPr/>
+      </p:nvGrpSpPr>
+      <p:grpSpPr/>
+      <p:sp>
+        <p:nvSpPr>
+          <p:cNvPr id="2" name="TextBox 1"/>
+          <p:cNvSpPr txBox="1"/>
+          <p:nvPr/>
+        </p:nvSpPr>
+        <p:spPr>
+          <a:xfrm>
+            <a:off x="640080" y="502920"/>
+            <a:ext cx="10881360" cy="365760"/>
+          </a:xfrm>
+          <a:prstGeom prst="rect">
+            <a:avLst/>
+          </a:prstGeom>
+          <a:noFill/>
+        </p:spPr>
+        <p:txBody>
+          <a:bodyPr wrap="square">
+            <a:noAutofit/>
+          </a:bodyPr>
+          <a:lstStyle/>
+          <a:p>
+            <a:r>
+              <a:rPr sz="1300" b="1" i="0" spc="150">
+                <a:solidFill>
+                  <a:srgbClr val="5B636C"/>
+                </a:solidFill>
+                <a:latin typeface="Arial"/>
+              </a:rPr>
+              <a:t>THE LINE WORTH HAVING READY</a:t>
+            </a:r>
+          </a:p>
+        </p:txBody>
+      </p:sp>
+      <p:sp>
+        <p:nvSpPr>
+          <p:cNvPr id="3" name="TextBox 2"/>
+          <p:cNvSpPr txBox="1"/>
+          <p:nvPr/>
+        </p:nvSpPr>
+        <p:spPr>
+          <a:xfrm>
+            <a:off x="640080" y="868680"/>
+            <a:ext cx="10881360" cy="1005840"/>
+          </a:xfrm>
+          <a:prstGeom prst="rect">
+            <a:avLst/>
+          </a:prstGeom>
+          <a:noFill/>
+        </p:spPr>
+        <p:txBody>
+          <a:bodyPr wrap="square">
+            <a:noAutofit/>
+          </a:bodyPr>
+          <a:lstStyle/>
+          <a:p>
+            <a:r>
+              <a:rPr sz="3200" b="1" i="0">
+                <a:solidFill>
+                  <a:srgbClr val="0F2A4A"/>
+                </a:solidFill>
+                <a:latin typeface="Arial"/>
+              </a:rPr>
+              <a:t>The common failure isn't malicious AI biology.</a:t>
+            </a:r>
+          </a:p>
+        </p:txBody>
+      </p:sp>
+      <p:sp>
+        <p:nvSpPr>
+          <p:cNvPr id="4" name="TextBox 3"/>
+          <p:cNvSpPr txBox="1"/>
+          <p:nvPr/>
+        </p:nvSpPr>
+        <p:spPr>
+          <a:xfrm>
+            <a:off x="640080" y="1920240"/>
+            <a:ext cx="10881360" cy="1737360"/>
+          </a:xfrm>
+          <a:prstGeom prst="rect">
+            <a:avLst/>
+          </a:prstGeom>
+          <a:noFill/>
+        </p:spPr>
+        <p:txBody>
+          <a:bodyPr wrap="square">
+            <a:noAutofit/>
+          </a:bodyPr>
+          <a:lstStyle/>
+          <a:p>
+            <a:r>
+              <a:rPr sz="2000" b="0" i="0">
+                <a:solidFill>
+                  <a:srgbClr val="1A1D21"/>
+                </a:solidFill>
+                <a:latin typeface="Arial"/>
+              </a:rPr>
+              <a:t>It's incompetent AI-designed biology — an agent proposing an experiment that cannot answer its own question, and nobody catching it because there's no simulator in the loop.</a:t>
+            </a:r>
+          </a:p>
+          <a:p>
+            <a:pPr>
+              <a:spcBef>
+                <a:spcPts val="1000"/>
+              </a:spcBef>
+            </a:pPr>
+            <a:r>
+              <a:rPr sz="2000" b="1" i="0">
+                <a:solidFill>
+                  <a:srgbClr val="0F2A4A"/>
+                </a:solidFill>
+                <a:latin typeface="Arial"/>
+              </a:rPr>
+              <a:t>That failure is measurable. This measures it against primary data.</a:t>
+            </a:r>
+          </a:p>
+        </p:txBody>
+      </p:sp>
+      <p:cxnSp>
+        <p:nvCxnSpPr>
+          <p:cNvPr id="5" name="Connector 4"/>
+          <p:cNvCxnSpPr/>
+          <p:nvPr/>
+        </p:nvCxnSpPr>
+        <p:spPr>
+          <a:xfrm>
+            <a:off x="640080" y="3931920"/>
+            <a:ext cx="10908792" cy="0"/>
+          </a:xfrm>
+          <a:prstGeom prst="line">
+            <a:avLst/>
+          </a:prstGeom>
+          <a:ln w="12700">
+            <a:solidFill>
+              <a:srgbClr val="DDE1E5"/>
+            </a:solidFill>
+          </a:ln>
+        </p:spPr>
+        <p:style>
+          <a:lnRef idx="2">
+            <a:schemeClr val="accent1"/>
+          </a:lnRef>
+          <a:fillRef idx="0">
+            <a:schemeClr val="accent1"/>
+          </a:fillRef>
+          <a:effectRef idx="1">
+            <a:schemeClr val="accent1"/>
+          </a:effectRef>
+          <a:fontRef idx="minor">
+            <a:schemeClr val="tx1"/>
+          </a:fontRef>
+        </p:style>
+      </p:cxnSp>
+      <p:sp>
+        <p:nvSpPr>
+          <p:cNvPr id="6" name="TextBox 5"/>
+          <p:cNvSpPr txBox="1"/>
+          <p:nvPr/>
+        </p:nvSpPr>
+        <p:spPr>
+          <a:xfrm>
             <a:off x="640080" y="4206240"/>
             <a:ext cx="10881360" cy="1828800"/>
           </a:xfrm>
@@ -6035,7 +6690,7 @@
                 </a:solidFill>
                 <a:latin typeface="Arial"/>
               </a:rPr>
-              <a:t>8</a:t>
+              <a:t>9</a:t>
             </a:r>
           </a:p>
         </p:txBody>

</xml_diff>

<commit_message>
Slide 7: real findings from the design-grounding sweep, not the search list
Replaces the generic "what we're searching for" bullets with the actual
result: Cre driver precedented but not adventitial-specific (Jones 2024
already used Pdgfra-CreERT2 in a PR8-family infection study), floxed
Ripk3/Mlkl never crossed to any fibroblast Cre in any tissue (real gap),
p-MLKL IHC strongly precedented on PR8-infected lung itself but flow on
dissociated cells has zero precedent (likely the same dissociation-loss
problem the original scRNA-seq hit), the IRFib hypothesis itself sits on
a real named population from an actual PR8 paper that never once looks at
death, and the ferroptosis arm is the weakest-grounded piece with no lung
BODIPY-C11 protocol anywhere.

Tightened text sizing (13pt, 8pt gap) since the real content is denser
than the placeholder list was.

🤖 Generated with [Claude Code](https://claude.com/claude-code)
Co-Authored-By: Claude Sonnet 5 <noreply@anthropic.com>
</commit_message>
<xml_diff>
--- a/talks/reagent_judging_5min.pptx
+++ b/talks/reagent_judging_5min.pptx
@@ -5561,7 +5561,7 @@
                 </a:solidFill>
                 <a:latin typeface="Arial"/>
               </a:rPr>
-              <a:t>NOTHING PREBUILT FITS — GROUND THE DESIGN DIRECTLY</a:t>
+              <a:t>NOTHING PREBUILT FITS — GROUNDED ANYWAY</a:t>
             </a:r>
           </a:p>
         </p:txBody>
@@ -5589,13 +5589,13 @@
           <a:lstStyle/>
           <a:p>
             <a:r>
-              <a:rPr sz="3200" b="1" i="0">
+              <a:rPr sz="2800" b="1" i="0">
                 <a:solidFill>
                   <a:srgbClr val="0F2A4A"/>
                 </a:solidFill>
                 <a:latin typeface="Arial"/>
               </a:rPr>
-              <a:t>The same Paperclip link, aimed at what's actually needed.</a:t>
+              <a:t>What's buildable, and what isn't.</a:t>
             </a:r>
           </a:p>
         </p:txBody>
@@ -5608,8 +5608,8 @@
         </p:nvSpPr>
         <p:spPr>
           <a:xfrm>
-            <a:off x="640080" y="1874519"/>
-            <a:ext cx="10881360" cy="3931920"/>
+            <a:off x="640080" y="1737360"/>
+            <a:ext cx="10881360" cy="4434840"/>
           </a:xfrm>
           <a:prstGeom prst="rect">
             <a:avLst/>
@@ -5624,81 +5624,126 @@
           <a:p>
             <a:pPr>
               <a:spcAft>
-                <a:spcPts val="1400"/>
+                <a:spcPts val="800"/>
               </a:spcAft>
             </a:pPr>
             <a:r>
-              <a:rPr sz="1700" b="0" i="0">
+              <a:rPr sz="1300" b="1" i="0">
+                <a:solidFill>
+                  <a:srgbClr val="0F2A4A"/>
+                </a:solidFill>
+                <a:latin typeface="Arial"/>
+              </a:rPr>
+              <a:t>Cre driver — precedented, not adventitial-specific.  </a:t>
+            </a:r>
+            <a:r>
+              <a:rPr sz="1300" b="0" i="0">
                 <a:solidFill>
                   <a:srgbClr val="1A1D21"/>
                 </a:solidFill>
                 <a:latin typeface="Arial"/>
               </a:rPr>
-              <a:t>A fibroblast-specific — ideally adventitial-specific — Cre driver line for mouse lung, published and available.</a:t>
+              <a:t>Pdgfra-CreERT2 already used in a PR8-family infection study (Jones 2024, Science) — true adventitial drivers (Pi16/Dpt) validated only in skin, never lung.</a:t>
             </a:r>
           </a:p>
           <a:p>
             <a:pPr>
               <a:spcAft>
-                <a:spcPts val="1400"/>
+                <a:spcPts val="800"/>
               </a:spcAft>
             </a:pPr>
             <a:r>
-              <a:rPr sz="1700" b="0" i="0">
+              <a:rPr sz="1300" b="1" i="0">
+                <a:solidFill>
+                  <a:srgbClr val="0F2A4A"/>
+                </a:solidFill>
+                <a:latin typeface="Arial"/>
+              </a:rPr>
+              <a:t>Floxed Ripk3/Mlkl — a real gap.  </a:t>
+            </a:r>
+            <a:r>
+              <a:rPr sz="1300" b="0" i="0">
                 <a:solidFill>
                   <a:srgbClr val="1A1D21"/>
                 </a:solidFill>
                 <a:latin typeface="Arial"/>
               </a:rPr>
-              <a:t>Floxed Ripk3 and Mlkl conditional alleles, and any prior study combining either with a fibroblast Cre.</a:t>
+              <a:t>Conditional alleles exist; none has ever been crossed to a fibroblast Cre, in any tissue. A from-scratch cross, not an ordering formality.</a:t>
             </a:r>
           </a:p>
           <a:p>
             <a:pPr>
               <a:spcAft>
-                <a:spcPts val="1400"/>
+                <a:spcPts val="800"/>
               </a:spcAft>
             </a:pPr>
             <a:r>
-              <a:rPr sz="1700" b="0" i="0">
+              <a:rPr sz="1300" b="1" i="0">
+                <a:solidFill>
+                  <a:srgbClr val="0F2A4A"/>
+                </a:solidFill>
+                <a:latin typeface="Arial"/>
+              </a:rPr>
+              <a:t>p-MLKL detection — the strongest-grounded piece.  </a:t>
+            </a:r>
+            <a:r>
+              <a:rPr sz="1300" b="0" i="0">
                 <a:solidFill>
                   <a:srgbClr val="1A1D21"/>
                 </a:solidFill>
                 <a:latin typeface="Arial"/>
               </a:rPr>
-              <a:t>Phospho-MLKL/phospho-RIPK3 detection validated in lung TISSUE, not just cell culture — and whether it survives dissociation.</a:t>
+              <a:t>IHC precedented on PR8-infected lung itself (Wang 2019), optimized on infected lung (Kelepouras 2024). Flow on dissociated cells has ZERO precedent — likely the same dissociation-loss problem the scRNA-seq hit.</a:t>
             </a:r>
           </a:p>
           <a:p>
             <a:pPr>
               <a:spcAft>
-                <a:spcPts val="1400"/>
+                <a:spcPts val="800"/>
               </a:spcAft>
             </a:pPr>
             <a:r>
-              <a:rPr sz="1700" b="0" i="0">
+              <a:rPr sz="1300" b="1" i="0">
+                <a:solidFill>
+                  <a:srgbClr val="0F2A4A"/>
+                </a:solidFill>
+                <a:latin typeface="Arial"/>
+              </a:rPr>
+              <a:t>The hypothesis itself is a real, unanswered gap.  </a:t>
+            </a:r>
+            <a:r>
+              <a:rPr sz="1300" b="0" i="0">
                 <a:solidFill>
                   <a:srgbClr val="1A1D21"/>
                 </a:solidFill>
                 <a:latin typeface="Arial"/>
               </a:rPr>
-              <a:t>Fibroblast-specific influenza necroptosis precedent, flagged explicitly if only epithelial-cell data exists as a proxy.</a:t>
+              <a:t>IRFibs are named, real cells from an actual PR8 paper (Boyd 2020, Nature) — which never looks at whether they die. No fibroblast-specific effect size exists to power against.</a:t>
             </a:r>
           </a:p>
           <a:p>
             <a:pPr>
               <a:spcAft>
-                <a:spcPts val="1400"/>
+                <a:spcPts val="800"/>
               </a:spcAft>
             </a:pPr>
             <a:r>
-              <a:rPr sz="1700" b="0" i="0">
+              <a:rPr sz="1300" b="1" i="0">
+                <a:solidFill>
+                  <a:srgbClr val="0F2A4A"/>
+                </a:solidFill>
+                <a:latin typeface="Arial"/>
+              </a:rPr>
+              <a:t>Ferroptosis arm — the weakest-grounded piece.  </a:t>
+            </a:r>
+            <a:r>
+              <a:rPr sz="1300" b="0" i="0">
                 <a:solidFill>
                   <a:srgbClr val="1A1D21"/>
                 </a:solidFill>
                 <a:latin typeface="Arial"/>
               </a:rPr>
-              <a:t>A flow-compatible ferroptosis readout (lipid peroxidation, GPX4) for the second arm the residual's own signal pointed toward.</a:t>
+              <a:t>No lung-flow protocol found anywhere for BODIPY-C11. Needs its own pilot first.</a:t>
             </a:r>
           </a:p>
         </p:txBody>

</xml_diff>